<commit_message>
sesión: setup infra completo + seed corporativo NexHealth/Coverwise
- Repo GitHub creado (mono-repo público, latam-tw excluido de Guilles-Universe)
- Cloudflare Pages conectado: deploy automático en push a main → dist/
- coverwise.becerra-ojeda.cl custom domain inicializando
- Seed corporativo: estructura-organizacional + estrategia-producto
- Bitácora actualizada con resumen completo de sesión

Co-Authored-By: Claude Sonnet 4.6 (1M context) <noreply@anthropic.com>
</commit_message>
<xml_diff>
--- a/_demo/E2E-SDPB-Coverwise-TW.pptx
+++ b/_demo/E2E-SDPB-Coverwise-TW.pptx
@@ -4131,22 +4131,31 @@
         <p:spPr>
           <a:xfrm>
             <a:off x="1908000" y="3348000"/>
-            <a:ext cx="4500000" cy="251999"/>
-          </a:xfrm>
-          <a:prstGeom prst="rect">
-            <a:avLst/>
-          </a:prstGeom>
-          <a:noFill/>
-        </p:spPr>
-        <p:txBody>
-          <a:bodyPr wrap="square">
-            <a:spAutoFit/>
-          </a:bodyPr>
-          <a:lstStyle/>
-          <a:p>
-            <a:pPr algn="l"/>
-            <a:r>
-              <a:rPr sz="1100" b="0" i="0">
+            <a:ext cx="4500000" cy="261610"/>
+          </a:xfrm>
+          <a:prstGeom prst="rect">
+            <a:avLst/>
+          </a:prstGeom>
+          <a:noFill/>
+        </p:spPr>
+        <p:txBody>
+          <a:bodyPr wrap="square">
+            <a:spAutoFit/>
+          </a:bodyPr>
+          <a:lstStyle/>
+          <a:p>
+            <a:pPr algn="l"/>
+            <a:r>
+              <a:rPr lang="es-419" sz="1100" b="0" i="0" dirty="0">
+                <a:solidFill>
+                  <a:srgbClr val="FFFFFF"/>
+                </a:solidFill>
+                <a:latin typeface="Calibri"/>
+              </a:rPr>
+              <a:t>Cloudflare Page+Workers  /</a:t>
+            </a:r>
+            <a:r>
+              <a:rPr sz="1100" b="0" i="0" dirty="0">
                 <a:solidFill>
                   <a:srgbClr val="FFFFFF"/>
                 </a:solidFill>

</xml_diff>